<commit_message>
Deploy to Cloud Run; real-Gemini deck screenshots; 30s storyboard image prompts
- First Cloud Run deployment (asia-southeast1, gemini-2.5-flash, local DuckDB, min 0 / max 1):
  R01 root cause High in 12.3 s, N01 insufficient evidence in 11.4 s
- /health route (Cloud Run reserves /healthz); capture-screens.py --base for remote URLs
- Deck screenshots re-captured from the deployment (no fixture banner)
- Dana: ChatGPT image prompts for the 30-second storyboard

Co-Authored-By: Claude Opus 5.5 <noreply@anthropic.com>
</commit_message>
<xml_diff>
--- a/docs/pitch/LineSleuth-demo.pptx
+++ b/docs/pitch/LineSleuth-demo.pptx
@@ -2027,7 +2027,7 @@
                 <a:ea typeface="Calibri" pitchFamily="34" charset="-122"/>
                 <a:cs typeface="Calibri" pitchFamily="34" charset="-120"/>
               </a:rPr>
-              <a:t>DRAFT · offline-mode capture, re-shoot in Gemini mode</a:t>
+              <a:t>Live prototype (Cloud Run, gemini-2.5-flash) · simulated plant data</a:t>
             </a:r>
             <a:endParaRPr lang="en-US" sz="1000" dirty="0"/>
           </a:p>
@@ -5700,7 +5700,7 @@
                 <a:ea typeface="Calibri" pitchFamily="34" charset="-122"/>
                 <a:cs typeface="Calibri" pitchFamily="34" charset="-120"/>
               </a:rPr>
-              <a:t>DRAFT · offline-mode capture, re-shoot in Gemini mode</a:t>
+              <a:t>Live prototype (Cloud Run, gemini-2.5-flash) · simulated plant data</a:t>
             </a:r>
             <a:endParaRPr lang="en-US" sz="1000" dirty="0"/>
           </a:p>
@@ -6508,7 +6508,7 @@
                 <a:ea typeface="Calibri" pitchFamily="34" charset="-122"/>
                 <a:cs typeface="Calibri" pitchFamily="34" charset="-120"/>
               </a:rPr>
-              <a:t>DRAFT · offline-mode capture, re-shoot in Gemini mode</a:t>
+              <a:t>Live prototype (Cloud Run, gemini-2.5-flash) · simulated plant data</a:t>
             </a:r>
             <a:endParaRPr lang="en-US" sz="1000" dirty="0"/>
           </a:p>
@@ -7505,7 +7505,7 @@
                 <a:ea typeface="Calibri" pitchFamily="34" charset="-122"/>
                 <a:cs typeface="Calibri" pitchFamily="34" charset="-120"/>
               </a:rPr>
-              <a:t>DRAFT · offline-mode capture, re-shoot in Gemini mode</a:t>
+              <a:t>Live prototype (Cloud Run, gemini-2.5-flash) · simulated plant data</a:t>
             </a:r>
             <a:endParaRPr lang="en-US" sz="1000" dirty="0"/>
           </a:p>

</xml_diff>

<commit_message>
Meeting 3: A1 at 720p, daily investigation cap, DuckDB wording, measured 12 s copy
- A1: 1280x720 shows 5 evidence rows after the conclusion (live, revision 00005)
- DAILY_INVESTIGATION_LIMIT (default 200/day, Asia/Taipei), friendly limit card, tests
- Docs, roadmap and deck: demo data on DuckDB, swappable for BigQuery (not 'supported')
- '90 sec' replaced with measured ~12 s (median 12.6 s, docs/qa/runs); 40 min stays pending
- Deck rebuilt (closing title, validation slide 10/10 and 2/2); one-pager PDF re-fitted to A4
- 30s storyboard prompts v0.2 (only frame 01 generated); roadmap dates; ROI token x price rows
- Meeting minutes docs/meetings/2026-09-24-部署後下一步.md

Co-Authored-By: Claude Opus 5.5 <noreply@anthropic.com>
</commit_message>
<xml_diff>
--- a/docs/pitch/LineSleuth-demo.pptx
+++ b/docs/pitch/LineSleuth-demo.pptx
@@ -2925,7 +2925,7 @@
               <a:buNone/>
             </a:pPr>
             <a:r>
-              <a:rPr lang="en-US" sz="8000" b="1" dirty="0">
+              <a:rPr lang="en-US" sz="5000" b="1" dirty="0">
                 <a:solidFill>
                   <a:srgbClr val="E8EAED"/>
                 </a:solidFill>
@@ -2933,13 +2933,13 @@
                 <a:ea typeface="Arial" pitchFamily="34" charset="-122"/>
                 <a:cs typeface="Arial" pitchFamily="34" charset="-120"/>
               </a:rPr>
-              <a:t>40 min </a:t>
+              <a:t>Stoppage </a:t>
             </a:r>
             <a:pPr algn="ctr" indent="0" marL="0">
               <a:buNone/>
             </a:pPr>
             <a:r>
-              <a:rPr lang="en-US" sz="8000" b="1" dirty="0">
+              <a:rPr lang="en-US" sz="5000" b="1" dirty="0">
                 <a:solidFill>
                   <a:srgbClr val="F5A524"/>
                 </a:solidFill>
@@ -2953,7 +2953,7 @@
               <a:buNone/>
             </a:pPr>
             <a:r>
-              <a:rPr lang="en-US" sz="8000" b="1" dirty="0">
+              <a:rPr lang="en-US" sz="5000" b="1" dirty="0">
                 <a:solidFill>
                   <a:srgbClr val="E8EAED"/>
                 </a:solidFill>
@@ -2961,9 +2961,9 @@
                 <a:ea typeface="Arial" pitchFamily="34" charset="-122"/>
                 <a:cs typeface="Arial" pitchFamily="34" charset="-120"/>
               </a:rPr>
-              <a:t>90 sec*</a:t>
-            </a:r>
-            <a:endParaRPr lang="en-US" sz="8000" dirty="0"/>
+              <a:t>root cause in ~12 s*</a:t>
+            </a:r>
+            <a:endParaRPr lang="en-US" sz="5000" dirty="0"/>
           </a:p>
         </p:txBody>
       </p:sp>
@@ -3014,8 +3014,8 @@
         </p:nvSpPr>
         <p:spPr>
           <a:xfrm>
-            <a:off x="3108960" y="4206240"/>
-            <a:ext cx="5971032" cy="1188720"/>
+            <a:off x="2194560" y="4206240"/>
+            <a:ext cx="7799832" cy="1188720"/>
           </a:xfrm>
           <a:prstGeom prst="roundRect">
             <a:avLst>
@@ -3041,8 +3041,8 @@
         </p:nvSpPr>
         <p:spPr>
           <a:xfrm>
-            <a:off x="3108960" y="4206240"/>
-            <a:ext cx="5971032" cy="1188720"/>
+            <a:off x="2194560" y="4206240"/>
+            <a:ext cx="7799832" cy="1188720"/>
           </a:xfrm>
           <a:prstGeom prst="rect">
             <a:avLst/>
@@ -3083,7 +3083,7 @@
                 <a:ea typeface="Calibri" pitchFamily="34" charset="-122"/>
                 <a:cs typeface="Calibri" pitchFamily="34" charset="-120"/>
               </a:rPr>
-              <a:t>hongchelai@gmail.com  ·  Live prototype: [Cloud Run URL / QR]</a:t>
+              <a:t>hongchelai@gmail.com  ·  Live prototype: linesleuth-547147056278.asia-southeast1.run.app</a:t>
             </a:r>
             <a:endParaRPr lang="en-US" sz="1700" dirty="0"/>
           </a:p>
@@ -3122,7 +3122,7 @@
                 <a:ea typeface="Calibri" pitchFamily="34" charset="-122"/>
                 <a:cs typeface="Calibri" pitchFamily="34" charset="-120"/>
               </a:rPr>
-              <a:t>* 40 min pending interviews · 90 sec pending measurement</a:t>
+              <a:t>* measured median 12.6 s per investigation (gemini-2.5-flash, 10 root causes × 3 runs, docs/qa/runs) · manual baseline pending interviews</a:t>
             </a:r>
             <a:endParaRPr lang="en-US" sz="1100" dirty="0"/>
           </a:p>
@@ -3362,7 +3362,7 @@
                 <a:ea typeface="Arial" pitchFamily="34" charset="-122"/>
                 <a:cs typeface="Arial" pitchFamily="34" charset="-120"/>
               </a:rPr>
-              <a:t>[to measure] / 10</a:t>
+              <a:t>10 / 10 (real Gemini)</a:t>
             </a:r>
             <a:endParaRPr lang="en-US" sz="1600" dirty="0"/>
           </a:p>
@@ -3492,7 +3492,7 @@
                 <a:ea typeface="Arial" pitchFamily="34" charset="-122"/>
                 <a:cs typeface="Arial" pitchFamily="34" charset="-120"/>
               </a:rPr>
-              <a:t>[to measure]</a:t>
+              <a:t>2 / 2</a:t>
             </a:r>
             <a:endParaRPr lang="en-US" sz="1600" dirty="0"/>
           </a:p>
@@ -3583,7 +3583,7 @@
                 <a:ea typeface="Calibri" pitchFamily="34" charset="-122"/>
                 <a:cs typeface="Calibri" pitchFamily="34" charset="-120"/>
               </a:rPr>
-              <a:t>Median time to conclusion</a:t>
+              <a:t>Median time to conclusion (gemini-2.5-flash, docs/qa/runs)</a:t>
             </a:r>
             <a:endParaRPr lang="en-US" sz="1700" dirty="0"/>
           </a:p>
@@ -3622,7 +3622,7 @@
                 <a:ea typeface="Arial" pitchFamily="34" charset="-122"/>
                 <a:cs typeface="Arial" pitchFamily="34" charset="-120"/>
               </a:rPr>
-              <a:t>[to measure] s</a:t>
+              <a:t>12.6 s</a:t>
             </a:r>
             <a:endParaRPr lang="en-US" sz="1600" dirty="0"/>
           </a:p>
@@ -6970,7 +6970,7 @@
                 <a:ea typeface="Calibri" pitchFamily="34" charset="-122"/>
                 <a:cs typeface="Calibri" pitchFamily="34" charset="-120"/>
               </a:rPr>
-              <a:t>Every number traces back to BigQuery.</a:t>
+              <a:t>Every number traces back to a source data row.</a:t>
             </a:r>
             <a:endParaRPr lang="en-US" sz="1300" dirty="0"/>
           </a:p>
@@ -7356,7 +7356,7 @@
                 <a:ea typeface="Calibri" pitchFamily="34" charset="-122"/>
                 <a:cs typeface="Calibri" pitchFamily="34" charset="-120"/>
               </a:rPr>
-              <a:t>* before-time pending interviews; after-time pending measurement.</a:t>
+              <a:t>* before-time pending interviews; after-time measured: median 12.6 s per investigation (gemini-2.5-flash, docs/qa/runs).</a:t>
             </a:r>
             <a:endParaRPr lang="en-US" sz="1000" dirty="0"/>
           </a:p>
@@ -8186,13 +8186,13 @@
             <a:r>
               <a:rPr lang="en-US" sz="1700" b="1" dirty="0">
                 <a:solidFill>
-                  <a:srgbClr val="5AA9FF"/>
+                  <a:srgbClr val="E8EAED"/>
                 </a:solidFill>
                 <a:latin typeface="Arial" pitchFamily="34" charset="0"/>
                 <a:ea typeface="Arial" pitchFamily="34" charset="-122"/>
                 <a:cs typeface="Arial" pitchFamily="34" charset="-120"/>
               </a:rPr>
-              <a:t>BigQuery</a:t>
+              <a:t>DuckDB · demo data</a:t>
             </a:r>
             <a:endParaRPr lang="en-US" sz="1700" dirty="0"/>
           </a:p>
@@ -8231,7 +8231,7 @@
                 <a:ea typeface="Calibri" pitchFamily="34" charset="-122"/>
                 <a:cs typeface="Calibri" pitchFamily="34" charset="-120"/>
               </a:rPr>
-              <a:t>Plant data · work orders</a:t>
+              <a:t>In the Cloud Run image · swappable for BigQuery</a:t>
             </a:r>
             <a:endParaRPr lang="en-US" sz="1300" dirty="0"/>
           </a:p>

</xml_diff>